<commit_message>
Group VLM safety references and add paper reading guide
</commit_message>
<xml_diff>
--- a/presentation/VLM_Safety_Alignment_Research_Proposal.pptx
+++ b/presentation/VLM_Safety_Alignment_Research_Proposal.pptx
@@ -35,6 +35,7 @@
     <p:sldId id="283" r:id="rId34"/>
     <p:sldId id="284" r:id="rId35"/>
     <p:sldId id="285" r:id="rId36"/>
+    <p:sldId id="286" r:id="rId37"/>
   </p:sldIdLst>
   <p:sldSz cx="12191695" cy="6858000" type="screen4x3"/>
   <p:notesSz cx="6858000" cy="9144000"/>
@@ -1227,7 +1228,7 @@
           <a:lstStyle/>
           <a:p>
             <a:r>
-              <a:t>“The bracketed citations on each slide point to the IEEE-style numbered bibliography at the end. We deliberately distinguish peer-reviewed proceedings from arXiv preprints, and we keep each paper’s reported score attached to its own model and evaluation protocol. The audit remains the detailed lookup document; you do not need to read it aloud.”</a:t>
+              <a:t>"The bracketed citations on each slide point to the IEEE-style numbered bibliography at the end. We deliberately distinguish peer-reviewed proceedings from arXiv preprints, and we keep each paper’s reported score attached to its own model and evaluation protocol. The audit is the synthesis; the linked VLM_PAPER_READING_GUIDE.md maps every numbered reference to the sections, figures, and tables to inspect in the original paper."</a:t>
             </a:r>
           </a:p>
           <a:p/>
@@ -2069,7 +2070,7 @@
           <a:lstStyle/>
           <a:p>
             <a:r>
-              <a:t>“These references cover the foundational attacks and datasets, the first direct alignment baselines, preference data, representation-gap work, and leakage-controlled evaluation. The arXiv number or DOI provides a stable way to retrieve each paper.”</a:t>
+              <a:t>"This page groups the training and data-alignment papers: VLGuard, SafeVLM, SPA-VL, ADPO, Think in Safety, and VSFA. Reference 26 is included only as project-history context; it is LLM-only, not VLM evidence. Citation numbers remain the same as on the slides."</a:t>
             </a:r>
           </a:p>
         </p:txBody>
@@ -2139,7 +2140,7 @@
           <a:lstStyle/>
           <a:p>
             <a:r>
-              <a:t>“This group contains safety calibration and compositional benchmarks, adversarial preference optimization, safety reasoning, ecological meme evaluation, recent reasoning-driven prompt rewriting, label-free visual alignment, and the unified benchmark. The venue and DOI identify the archival published work; MMJailBench is clearly marked as a preprint.”</a:t>
+              <a:t>“This page groups representation correction, reasoning-driven prompt rewriting, test-time alignment, decoding interventions, and token-level selective defenses. It mixes peer-reviewed papers and preprints, so preserve the publication-status labels.”</a:t>
             </a:r>
           </a:p>
         </p:txBody>
@@ -2285,7 +2286,77 @@
           <a:lstStyle/>
           <a:p>
             <a:r>
-              <a:t>“The final references cover adaptive and internal-boundary attacks, recent test-time and decoding defenses, and representation calibration. Reference 26 is the prior LLM-only gradient-selection paper. It is included to document project history and is explicitly not treated as VLM-safety evidence.”</a:t>
+              <a:t>“This page groups the image-carrier, visual-semantic, benchmark-collection, adaptive black-box, and internal-boundary attack work. These papers define different attacker capabilities; do not treat their scores as one comparable leaderboard.”</a:t>
+            </a:r>
+          </a:p>
+        </p:txBody>
+      </p:sp>
+      <p:sp>
+        <p:nvSpPr>
+          <p:cNvPr id="4" name="Slide Number Placeholder 3"/>
+          <p:cNvSpPr>
+            <a:spLocks noGrp="1"/>
+          </p:cNvSpPr>
+          <p:nvPr>
+            <p:ph type="sldNum" idx="5" sz="quarter"/>
+          </p:nvPr>
+        </p:nvSpPr>
+        <p:spPr/>
+      </p:sp>
+    </p:spTree>
+  </p:cSld>
+  <p:clrMapOvr>
+    <a:masterClrMapping/>
+  </p:clrMapOvr>
+</p:notes>
+</file>
+
+<file path=ppt/notesSlides/notesSlide31.xml><?xml version="1.0" encoding="utf-8"?>
+<p:notes xmlns:a="http://schemas.openxmlformats.org/drawingml/2006/main" xmlns:p="http://schemas.openxmlformats.org/presentationml/2006/main" xmlns:r="http://schemas.openxmlformats.org/officeDocument/2006/relationships">
+  <p:cSld>
+    <p:spTree>
+      <p:nvGrpSpPr>
+        <p:cNvPr id="1" name=""/>
+        <p:cNvGrpSpPr/>
+        <p:nvPr/>
+      </p:nvGrpSpPr>
+      <p:grpSpPr>
+        <a:xfrm>
+          <a:off x="0" y="0"/>
+          <a:ext cx="0" cy="0"/>
+          <a:chOff x="0" y="0"/>
+          <a:chExt cx="0" cy="0"/>
+        </a:xfrm>
+      </p:grpSpPr>
+      <p:sp>
+        <p:nvSpPr>
+          <p:cNvPr id="2" name="Slide Image Placeholder 1"/>
+          <p:cNvSpPr>
+            <a:spLocks noGrp="1"/>
+          </p:cNvSpPr>
+          <p:nvPr>
+            <p:ph type="sldImg" idx="2"/>
+          </p:nvPr>
+        </p:nvSpPr>
+        <p:spPr/>
+      </p:sp>
+      <p:sp>
+        <p:nvSpPr>
+          <p:cNvPr id="3" name="Notes Placeholder 2"/>
+          <p:cNvSpPr>
+            <a:spLocks noGrp="1"/>
+          </p:cNvSpPr>
+          <p:nvPr>
+            <p:ph type="body" idx="3" sz="quarter"/>
+          </p:nvPr>
+        </p:nvSpPr>
+        <p:spPr/>
+        <p:txBody>
+          <a:bodyPr/>
+          <a:lstStyle/>
+          <a:p>
+            <a:r>
+              <a:t>“This page groups the broad safety, leakage, calibration, compositional, ecological, and risk-by-modality evaluations. SPA-VL and VLGuard are listed on the training page because their primary role here is alignment data/method; they also appear as resources in the benchmark audit. Use the protocol audit for the detailed dataset cards and caveats.”</a:t>
             </a:r>
           </a:p>
           <a:p/>
@@ -22327,7 +22398,7 @@
                 </a:solidFill>
                 <a:latin typeface="Aptos"/>
               </a:rPr>
-              <a:t>References [1]–[9]</a:t>
+              <a:t>References: Training, Data &amp; Project Context</a:t>
             </a:r>
           </a:p>
         </p:txBody>
@@ -22475,11 +22546,10 @@
                 </a:solidFill>
                 <a:latin typeface="Aptos"/>
               </a:rPr>
-              <a:t>[1] Y. Gong et al., "FigStep: Jailbreaking Large Vision-Language Models via Typographic Visual Prompts," arXiv:2311.05608, 2023.
-[2] X. Liu et al., "MM-SafetyBench: A Benchmark for Safety Evaluation of Multimodal Large Language Models," arXiv:2311.17600, 2023; accepted to ECCV 2024.
-[3] Y. Li et al., "Images are Achilles’ Heel of Alignment: Exploiting Visual Vulnerabilities for Jailbreaking Multimodal Large Language Models," arXiv:2403.09792, 2024.
-[4] W. Luo et al., "JailBreakV: A Benchmark for Assessing the Robustness of Multimodal Large Language Models against Jailbreak Attacks," arXiv:2404.03027, 2024.
-[5] Y. Zong et al., "Safety Fine-Tuning at (Almost) No Cost: A Baseline for Vision Large Language Models," arXiv:2402.02207, 2024.</a:t>
+              <a:t>[5] Y. Zong et al., "Safety Fine-Tuning at (Almost) No Cost: A Baseline for Vision Large Language Models," arXiv:2402.02207, 2024.
+[6] Z. Liu et al., "Safety Alignment for Vision Language Models," arXiv:2405.13581, 2024.
+[7] Y. Zhang et al., "SPA-VL: A Comprehensive Safety Preference Alignment Dataset for Vision-Language Models," in Proc. IEEE/CVF Conf. Comput. Vis. Pattern Recognit. (CVPR), 2025.
+[12] F. Weng et al., "Adversary-Aware DPO: Enhancing Safety Alignment in Vision Language Models via Adversarial Training," in Findings Assoc. Comput. Linguistics: EMNLP, pp. 13644–13657, 2025, doi: 10.18653/v1/2025.findings-emnlp.735.</a:t>
             </a:r>
           </a:p>
         </p:txBody>
@@ -22514,10 +22584,9 @@
                 </a:solidFill>
                 <a:latin typeface="Aptos"/>
               </a:rPr>
-              <a:t>[6] Z. Liu et al., "Safety Alignment for Vision Language Models," arXiv:2405.13581, 2024.
-[7] Y. Zhang et al., "SPA-VL: A Comprehensive Safety Preference Alignment Dataset for Vision-Language Models," in Proc. IEEE/CVF Conf. Comput. Vis. Pattern Recognit. (CVPR), 2025.
-[8] Q. Liu et al., "Unraveling and Mitigating Safety Alignment Degradation of Vision-Language Models," in Findings Assoc. Comput. Linguistics: ACL, pp. 3631–3643, 2025, doi: 10.18653/v1/2025.findings-acl.186.
-[9] X. Hu et al., "VLSBench: Unveiling Visual Leakage in Multimodal Safety," in Proc. 63rd Annu. Meeting Assoc. Comput. Linguistics (ACL), pp. 8285–8316, 2025, doi: 10.18653/v1/2025.acl-long.405.</a:t>
+              <a:t>[13] X. Lou et al., "Think in Safety: Unveiling and Mitigating Safety Alignment Collapse in Multimodal Large Reasoning Model," in Proc. Conf. Empirical Methods Natural Language Process. (EMNLP), pp. 5167–5186, 2025.
+[16] Q. Yang et al., "Visual Self-Fulfilling Alignment: Shaping Safety-Oriented Personas via Threat-Related Images," in Proc. 64th Annu. Meeting Assoc. Comput. Linguistics (ACL), pp. 10698–10718, 2026, doi: 10.18653/v1/2026.acl-long.490.
+[26] T. Bach et al., "Continual Safety Alignment via Gradient-Based Sample Selection," arXiv:2604.17215, 2026. LLM-only; project-history context, not VLM evidence.</a:t>
             </a:r>
           </a:p>
         </p:txBody>
@@ -22613,7 +22682,7 @@
                 </a:solidFill>
                 <a:latin typeface="Aptos"/>
               </a:rPr>
-              <a:t>References [10]–[18]</a:t>
+              <a:t>References: Inference and Runtime Defenses</a:t>
             </a:r>
           </a:p>
         </p:txBody>
@@ -22761,11 +22830,10 @@
                 </a:solidFill>
                 <a:latin typeface="Aptos"/>
               </a:rPr>
-              <a:t>[10] J. Geng et al., "VSCBench: Bridging the Gap in Vision-Language Model Safety Calibration," in Findings Assoc. Comput. Linguistics: ACL, pp. 3047–3059, 2025, doi: 10.18653/v1/2025.findings-acl.158.
-[11] S. Wang et al., "Safe Inputs but Unsafe Output: Benchmarking Cross-modality Safety Alignment of Large Vision-Language Models," in Findings Assoc. Comput. Linguistics: NAACL, pp. 3563–3605, 2025, doi: 10.18653/v1/2025.findings-naacl.198.
-[12] F. Weng et al., "Adversary-Aware DPO: Enhancing Safety Alignment in Vision Language Models via Adversarial Training," in Findings Assoc. Comput. Linguistics: EMNLP, pp. 13644–13657, 2025, doi: 10.18653/v1/2025.findings-emnlp.735.
-[13] X. Lou et al., "Think in Safety: Unveiling and Mitigating Safety Alignment Collapse in Multimodal Large Reasoning Model," in Proc. Conf. Empirical Methods Natural Language Process. (EMNLP), pp. 5167–5186, 2025.
-[14] D. Lee et al., "Are Vision-Language Models Safe in the Wild? A Meme-Based Benchmark Study," in Proc. Conf. Empirical Methods Natural Language Process. (EMNLP), pp. 30545–30588, 2025, doi: 10.18653/v1/2025.emnlp-main.1555.</a:t>
+              <a:t>[8] Q. Liu et al., "Unraveling and Mitigating Safety Alignment Degradation of Vision-Language Models," in Findings Assoc. Comput. Linguistics: ACL, pp. 3631–3643, 2025, doi: 10.18653/v1/2025.findings-acl.186.
+[15] M. Chen et al., "VLMGuard-R1: Proactive Safety Alignment for VLMs via Reasoning-Driven Prompt Optimization," in Findings Assoc. Comput. Linguistics: ACL, pp. 39914–39932, 2026, doi: 10.18653/v1/2026.findings-acl.1986.
+[21] X. Zhu et al., "GuardAlign: Test-Time Safety Alignment in Multimodal Large Language Models," in Proc. Int. Conf. Learn. Represent. (ICLR), 2026.
+[22] X. Zeng et al., "SafeSteer: A Decoding-Level Defense Mechanism for Multimodal Large Language Models," in Findings Assoc. Comput. Linguistics: ACL, 2026.</a:t>
             </a:r>
           </a:p>
         </p:txBody>
@@ -22800,10 +22868,9 @@
                 </a:solidFill>
                 <a:latin typeface="Aptos"/>
               </a:rPr>
-              <a:t>[15] M. Chen et al., "VLMGuard-R1: Proactive Safety Alignment for VLMs via Reasoning-Driven Prompt Optimization," in Findings Assoc. Comput. Linguistics: ACL, pp. 39914–39932, 2026, doi: 10.18653/v1/2026.findings-acl.1986.
-[16] Q. Yang et al., "Visual Self-Fulfilling Alignment: Shaping Safety-Oriented Personas via Threat-Related Images," in Proc. 64th Annu. Meeting Assoc. Comput. Linguistics (ACL), pp. 10698–10718, 2026, doi: 10.18653/v1/2026.acl-long.490.
-[17] B. Zheng et al., "USB: A Comprehensive and Unified Safety Evaluation Benchmark for Multimodal Large Language Models," in Proc. 64th Annu. Meeting Assoc. Comput. Linguistics (ACL), pp. 21184–21211, 2026, doi: 10.18653/v1/2026.acl-long.970.
-[18] T. Wang et al., "MMJailBench: A Factorized Benchmark for Disentangling Multimodal Jailbreak Vulnerabilities," arXiv:2608.25490, 2026 (preprint).</a:t>
+              <a:t>[23] C. Ma et al., "SafeRI: Recognition and Intervention for Token-Level Safety Intervention in Large Vision Language Models," arXiv:2609.03544, 2026 (preprint).
+[24] P. Tang et al., "SafetyReminder: Reviving Delayed Safety Awareness of Vision-Language Models to Defend Against Jailbreak Attacks," in Proc. AAAI Conf. Artif. Intell., vol. 40, no. 39, pp. 33223–33231, 2026, doi: 10.1609/aaai.v40i39.40607.
+[25] S. Zhang et al., "MMAligner: Safeguarding Multimodal Large Language Models through Representation Calibration," arXiv:2608.05909, 2026 (preprint).</a:t>
             </a:r>
           </a:p>
         </p:txBody>
@@ -23620,7 +23687,7 @@
                 </a:solidFill>
                 <a:latin typeface="Aptos"/>
               </a:rPr>
-              <a:t>References [19]–[26]</a:t>
+              <a:t>References: Attacks and Red Teaming</a:t>
             </a:r>
           </a:p>
         </p:txBody>
@@ -23768,10 +23835,9 @@
                 </a:solidFill>
                 <a:latin typeface="Aptos"/>
               </a:rPr>
-              <a:t>[19] X. Wang et al., "PolyJailbreak: Cross-Modal Jailbreaking Attacks on Black-Box Multimodal LLMs," arXiv:2510.17277, 2025 (preprint).
-[20] J. Song et al., "JailBound: Jailbreaking Internal Safety Boundaries of Vision-Language Models," in Adv. Neural Inf. Process. Syst. (NeurIPS), 2025, doi: 10.52202/085713-0875.
-[21] X. Zhu et al., "GuardAlign: Test-Time Safety Alignment in Multimodal Large Language Models," in Proc. Int. Conf. Learn. Represent. (ICLR), 2026.
-[22] X. Zeng et al., "SafeSteer: A Decoding-Level Defense Mechanism for Multimodal Large Language Models," in Findings Assoc. Comput. Linguistics: ACL, 2026.</a:t>
+              <a:t>[1] Y. Gong et al., "FigStep: Jailbreaking Large Vision-Language Models via Typographic Visual Prompts," arXiv:2311.05608, 2023.
+[3] Y. Li et al., "Images are Achilles’ Heel of Alignment: Exploiting Visual Vulnerabilities for Jailbreaking Multimodal Large Language Models," arXiv:2403.09792, 2024.
+[4] W. Luo et al., "JailBreakV: A Benchmark for Assessing the Robustness of Multimodal Large Language Models against Jailbreak Attacks," arXiv:2404.03027, 2024.</a:t>
             </a:r>
           </a:p>
         </p:txBody>
@@ -23806,10 +23872,292 @@
                 </a:solidFill>
                 <a:latin typeface="Aptos"/>
               </a:rPr>
-              <a:t>[23] C. Ma et al., "SafeRI: Recognition and Intervention for Token-Level Safety Intervention in Large Vision Language Models," arXiv:2609.03544, 2026 (preprint).
-[24] P. Tang et al., "SafetyReminder: Reviving Delayed Safety Awareness of Vision-Language Models to Defend Against Jailbreak Attacks," in Proc. AAAI Conf. Artif. Intell., vol. 40, no. 39, pp. 33223–33231, 2026, doi: 10.1609/aaai.v40i39.40607.
-[25] S. Zhang et al., "MMAligner: Safeguarding Multimodal Large Language Models through Representation Calibration," arXiv:2608.05909, 2026 (preprint).
-[26] T. Bach et al., "Continual Safety Alignment via Gradient-Based Sample Selection," arXiv:2604.17215, 2026. LLM-only; project-history context, not VLM evidence.</a:t>
+              <a:t>[19] X. Wang et al., "PolyJailbreak: Cross-Modal Jailbreaking Attacks on Black-Box Multimodal LLMs," arXiv:2510.17277, 2025 (preprint).
+[20] J. Song et al., "JailBound: Jailbreaking Internal Safety Boundaries of Vision-Language Models," in Adv. Neural Inf. Process. Syst. (NeurIPS), 2025, doi: 10.52202/085713-0875.</a:t>
+            </a:r>
+          </a:p>
+        </p:txBody>
+      </p:sp>
+    </p:spTree>
+  </p:cSld>
+  <p:clrMapOvr>
+    <a:masterClrMapping/>
+  </p:clrMapOvr>
+</p:sld>
+</file>
+
+<file path=ppt/slides/slide31.xml><?xml version="1.0" encoding="utf-8"?>
+<p:sld xmlns:a="http://schemas.openxmlformats.org/drawingml/2006/main" xmlns:p="http://schemas.openxmlformats.org/presentationml/2006/main" xmlns:r="http://schemas.openxmlformats.org/officeDocument/2006/relationships">
+  <p:cSld>
+    <p:bg>
+      <p:bgPr>
+        <a:solidFill>
+          <a:srgbClr val="FFFFFF"/>
+        </a:solidFill>
+        <a:effectLst/>
+      </p:bgPr>
+    </p:bg>
+    <p:spTree>
+      <p:nvGrpSpPr>
+        <p:cNvPr id="1" name=""/>
+        <p:cNvGrpSpPr/>
+        <p:nvPr/>
+      </p:nvGrpSpPr>
+      <p:grpSpPr/>
+      <p:sp>
+        <p:nvSpPr>
+          <p:cNvPr id="2" name="TextBox 1"/>
+          <p:cNvSpPr txBox="1"/>
+          <p:nvPr/>
+        </p:nvSpPr>
+        <p:spPr>
+          <a:xfrm>
+            <a:off x="566928" y="292608"/>
+            <a:ext cx="2377440" cy="256032"/>
+          </a:xfrm>
+          <a:prstGeom prst="rect">
+            <a:avLst/>
+          </a:prstGeom>
+          <a:noFill/>
+        </p:spPr>
+        <p:txBody>
+          <a:bodyPr wrap="square" lIns="18288" rIns="18288" tIns="18288" bIns="18288" anchor="t">
+            <a:spAutoFit/>
+          </a:bodyPr>
+          <a:lstStyle/>
+          <a:p>
+            <a:pPr algn="l"/>
+            <a:r>
+              <a:rPr sz="1000" b="1">
+                <a:solidFill>
+                  <a:srgbClr val="276B7E"/>
+                </a:solidFill>
+                <a:latin typeface="Aptos"/>
+              </a:rPr>
+              <a:t>IEEE REFERENCES</a:t>
+            </a:r>
+          </a:p>
+        </p:txBody>
+      </p:sp>
+      <p:sp>
+        <p:nvSpPr>
+          <p:cNvPr id="3" name="TextBox 2"/>
+          <p:cNvSpPr txBox="1"/>
+          <p:nvPr/>
+        </p:nvSpPr>
+        <p:spPr>
+          <a:xfrm>
+            <a:off x="566928" y="621792"/>
+            <a:ext cx="10972800" cy="594360"/>
+          </a:xfrm>
+          <a:prstGeom prst="rect">
+            <a:avLst/>
+          </a:prstGeom>
+          <a:noFill/>
+        </p:spPr>
+        <p:txBody>
+          <a:bodyPr wrap="square" lIns="18288" rIns="18288" tIns="18288" bIns="18288" anchor="t">
+            <a:spAutoFit/>
+          </a:bodyPr>
+          <a:lstStyle/>
+          <a:p>
+            <a:pPr algn="l"/>
+            <a:r>
+              <a:rPr sz="2600" b="1">
+                <a:solidFill>
+                  <a:srgbClr val="122A42"/>
+                </a:solidFill>
+                <a:latin typeface="Aptos"/>
+              </a:rPr>
+              <a:t>References: Benchmarks and Datasets</a:t>
+            </a:r>
+          </a:p>
+        </p:txBody>
+      </p:sp>
+      <p:sp>
+        <p:nvSpPr>
+          <p:cNvPr id="4" name="Rectangle 3"/>
+          <p:cNvSpPr/>
+          <p:nvPr/>
+        </p:nvSpPr>
+        <p:spPr>
+          <a:xfrm>
+            <a:off x="566928" y="1307592"/>
+            <a:ext cx="11018520" cy="13716"/>
+          </a:xfrm>
+          <a:prstGeom prst="rect">
+            <a:avLst/>
+          </a:prstGeom>
+          <a:solidFill>
+            <a:srgbClr val="DAE2DF"/>
+          </a:solidFill>
+          <a:ln>
+            <a:noFill/>
+          </a:ln>
+        </p:spPr>
+        <p:style>
+          <a:lnRef idx="1">
+            <a:schemeClr val="accent1"/>
+          </a:lnRef>
+          <a:fillRef idx="3">
+            <a:schemeClr val="accent1"/>
+          </a:fillRef>
+          <a:effectRef idx="2">
+            <a:schemeClr val="accent1"/>
+          </a:effectRef>
+          <a:fontRef idx="minor">
+            <a:schemeClr val="lt1"/>
+          </a:fontRef>
+        </p:style>
+        <p:txBody>
+          <a:bodyPr rtlCol="0" anchor="ctr"/>
+          <a:lstStyle/>
+          <a:p>
+            <a:pPr algn="ctr"/>
+          </a:p>
+        </p:txBody>
+      </p:sp>
+      <p:sp>
+        <p:nvSpPr>
+          <p:cNvPr id="5" name="TextBox 4"/>
+          <p:cNvSpPr txBox="1"/>
+          <p:nvPr/>
+        </p:nvSpPr>
+        <p:spPr>
+          <a:xfrm>
+            <a:off x="566928" y="6528816"/>
+            <a:ext cx="9966960" cy="182880"/>
+          </a:xfrm>
+          <a:prstGeom prst="rect">
+            <a:avLst/>
+          </a:prstGeom>
+          <a:noFill/>
+        </p:spPr>
+        <p:txBody>
+          <a:bodyPr wrap="square" lIns="18288" rIns="18288" tIns="18288" bIns="18288" anchor="t">
+            <a:spAutoFit/>
+          </a:bodyPr>
+          <a:lstStyle/>
+          <a:p>
+            <a:pPr algn="l"/>
+            <a:r>
+              <a:rPr sz="800" b="0">
+                <a:solidFill>
+                  <a:srgbClr val="64707B"/>
+                </a:solidFill>
+                <a:latin typeface="Aptos"/>
+              </a:rPr>
+              <a:t>Full citation metadata; numbered entries correspond to in-slide citations</a:t>
+            </a:r>
+          </a:p>
+        </p:txBody>
+      </p:sp>
+      <p:sp>
+        <p:nvSpPr>
+          <p:cNvPr id="6" name="TextBox 5"/>
+          <p:cNvSpPr txBox="1"/>
+          <p:nvPr/>
+        </p:nvSpPr>
+        <p:spPr>
+          <a:xfrm>
+            <a:off x="10972800" y="6492240"/>
+            <a:ext cx="640080" cy="228600"/>
+          </a:xfrm>
+          <a:prstGeom prst="rect">
+            <a:avLst/>
+          </a:prstGeom>
+          <a:noFill/>
+        </p:spPr>
+        <p:txBody>
+          <a:bodyPr wrap="square" lIns="18288" rIns="18288" tIns="18288" bIns="18288" anchor="t">
+            <a:spAutoFit/>
+          </a:bodyPr>
+          <a:lstStyle/>
+          <a:p>
+            <a:pPr algn="r"/>
+            <a:r>
+              <a:rPr sz="900" b="0">
+                <a:solidFill>
+                  <a:srgbClr val="64707B"/>
+                </a:solidFill>
+                <a:latin typeface="Aptos"/>
+              </a:rPr>
+              <a:t>31</a:t>
+            </a:r>
+          </a:p>
+        </p:txBody>
+      </p:sp>
+      <p:sp>
+        <p:nvSpPr>
+          <p:cNvPr id="7" name="TextBox 6"/>
+          <p:cNvSpPr txBox="1"/>
+          <p:nvPr/>
+        </p:nvSpPr>
+        <p:spPr>
+          <a:xfrm>
+            <a:off x="713232" y="1600200"/>
+            <a:ext cx="5285232" cy="4681728"/>
+          </a:xfrm>
+          <a:prstGeom prst="rect">
+            <a:avLst/>
+          </a:prstGeom>
+          <a:noFill/>
+        </p:spPr>
+        <p:txBody>
+          <a:bodyPr wrap="square" lIns="18288" rIns="18288" tIns="18288" bIns="18288" anchor="t">
+            <a:spAutoFit/>
+          </a:bodyPr>
+          <a:lstStyle/>
+          <a:p>
+            <a:pPr algn="l"/>
+            <a:r>
+              <a:rPr sz="1120" b="0">
+                <a:solidFill>
+                  <a:srgbClr val="1C2A39"/>
+                </a:solidFill>
+                <a:latin typeface="Aptos"/>
+              </a:rPr>
+              <a:t>[2] X. Liu et al., "MM-SafetyBench: A Benchmark for Safety Evaluation of Multimodal Large Language Models," arXiv:2311.17600, 2023; accepted to ECCV 2024.
+[9] X. Hu et al., "VLSBench: Unveiling Visual Leakage in Multimodal Safety," in Proc. 63rd Annu. Meeting Assoc. Comput. Linguistics (ACL), pp. 8285–8316, 2025, doi: 10.18653/v1/2025.acl-long.405.
+[10] J. Geng et al., "VSCBench: Bridging the Gap in Vision-Language Model Safety Calibration," in Findings Assoc. Comput. Linguistics: ACL, pp. 3047–3059, 2025, doi: 10.18653/v1/2025.findings-acl.158.
+[11] S. Wang et al., "Safe Inputs but Unsafe Output: Benchmarking Cross-modality Safety Alignment of Large Vision-Language Models," in Findings Assoc. Comput. Linguistics: NAACL, pp. 3563–3605, 2025, doi: 10.18653/v1/2025.findings-naacl.198.</a:t>
+            </a:r>
+          </a:p>
+        </p:txBody>
+      </p:sp>
+      <p:sp>
+        <p:nvSpPr>
+          <p:cNvPr id="8" name="TextBox 7"/>
+          <p:cNvSpPr txBox="1"/>
+          <p:nvPr/>
+        </p:nvSpPr>
+        <p:spPr>
+          <a:xfrm>
+            <a:off x="6245352" y="1600200"/>
+            <a:ext cx="5285232" cy="4681728"/>
+          </a:xfrm>
+          <a:prstGeom prst="rect">
+            <a:avLst/>
+          </a:prstGeom>
+          <a:noFill/>
+        </p:spPr>
+        <p:txBody>
+          <a:bodyPr wrap="square" lIns="18288" rIns="18288" tIns="18288" bIns="18288" anchor="t">
+            <a:spAutoFit/>
+          </a:bodyPr>
+          <a:lstStyle/>
+          <a:p>
+            <a:pPr algn="l"/>
+            <a:r>
+              <a:rPr sz="1120" b="0">
+                <a:solidFill>
+                  <a:srgbClr val="1C2A39"/>
+                </a:solidFill>
+                <a:latin typeface="Aptos"/>
+              </a:rPr>
+              <a:t>[14] D. Lee et al., "Are Vision-Language Models Safe in the Wild? A Meme-Based Benchmark Study," in Proc. Conf. Empirical Methods Natural Language Process. (EMNLP), pp. 30545–30588, 2025, doi: 10.18653/v1/2025.emnlp-main.1555.
+[17] B. Zheng et al., "USB: A Comprehensive and Unified Safety Evaluation Benchmark for Multimodal Large Language Models," in Proc. 64th Annu. Meeting Assoc. Comput. Linguistics (ACL), pp. 21184–21211, 2026, doi: 10.18653/v1/2026.acl-long.970.
+[18] T. Wang et al., "MMJailBench: A Factorized Benchmark for Disentangling Multimodal Jailbreak Vulnerabilities," arXiv:2608.25490, 2026 (preprint).</a:t>
             </a:r>
           </a:p>
         </p:txBody>

</xml_diff>